<commit_message>
fixed 4 to i3 and i8
</commit_message>
<xml_diff>
--- a/docs/ecostats_lectures/lecture_04/04_01_lecture_powerpoint.pptx
+++ b/docs/ecostats_lectures/lecture_04/04_01_lecture_powerpoint.pptx
@@ -3630,7 +3630,7 @@
                         <m:sSub>
                           <m:e>
                             <m:r>
-                              <m:t>X</m:t>
+                              <m:t>x</m:t>
                             </m:r>
                           </m:e>
                           <m:sub>
@@ -3733,7 +3733,7 @@
                 </a:solidFill>
                 <a:latin typeface="Courier"/>
               </a:rPr>
-              <a:t>i3_stats &lt;- gray_i3_df </a:t>
+              <a:t>i3_stats &lt;- i3_df </a:t>
             </a:r>
             <a:r>
               <a:rPr>
@@ -4448,7 +4448,7 @@
                 </a:pPr>
                 <a:r>
                   <a:rPr/>
-                  <a:t>So lets do this for a fish that is 320mm long and guess the probability of catching something larger</a:t>
+                  <a:t>So lets do this for a fish that is 300mm long and guess the probability of catching something larger</a:t>
                 </a:r>
               </a:p>
               <a:p>
@@ -4457,7 +4457,7 @@
                 </a:pPr>
                 <a:r>
                   <a:rPr/>
-                  <a:t>z = (320 - 265.61)/28.3 = 1.92</a:t>
+                  <a:t>z = (300 - 265.61)/28.3 = 1.22</a:t>
                 </a:r>
               </a:p>
               <a:p>
@@ -4466,7 +4466,7 @@
                 </a:pPr>
                 <a:r>
                   <a:rPr/>
-                  <a:t>or .9726 in table or 97.3% is the area left of the curve and</a:t>
+                  <a:t>or 0.8888 in table or 88.9% is the area left of the curve and</a:t>
                 </a:r>
               </a:p>
               <a:p>
@@ -4475,7 +4475,25 @@
                 </a:pPr>
                 <a:r>
                   <a:rPr/>
-                  <a:t>100 - 97.3 = 2.7% or 2.7% of fish are expected to be longer</a:t>
+                  <a:t>100 - 88.9 = 11.27% or 11.2% of fish are expected to be longer</a:t>
+                </a:r>
+              </a:p>
+              <a:p>
+                <a:pPr lvl="0" indent="0" marL="0">
+                  <a:buNone/>
+                </a:pPr>
+                <a:r>
+                  <a:rPr/>
+                  <a:t>So do you think you can catch something larger than 300 mm?</a:t>
+                </a:r>
+              </a:p>
+              <a:p>
+                <a:pPr lvl="0" indent="0" marL="0">
+                  <a:buNone/>
+                </a:pPr>
+                <a:r>
+                  <a:rPr/>
+                  <a:t>At what point do you think its not likely?</a:t>
                 </a:r>
               </a:p>
             </p:txBody>
@@ -4734,14 +4752,14 @@
               <a:p>
                 <a:pPr lvl="0"/>
                 <a:r>
-                  <a:rPr/>
+                  <a:rPr b="1"/>
                   <a:t>SEM is used to construct confidence intervals</a:t>
                 </a:r>
               </a:p>
               <a:p>
                 <a:pPr lvl="0"/>
                 <a:r>
-                  <a:rPr/>
+                  <a:rPr b="1"/>
                   <a:t>SEM measures the precision of the sample mean</a:t>
                 </a:r>
               </a:p>
@@ -4977,7 +4995,7 @@
                 </a:solidFill>
                 <a:latin typeface="Courier"/>
               </a:rPr>
-              <a:t>5</a:t>
+              <a:t>3</a:t>
             </a:r>
             <a:r>
               <a:rPr>
@@ -5105,7 +5123,7 @@
                 </a:solidFill>
                 <a:latin typeface="Courier"/>
               </a:rPr>
-              <a:t>125</a:t>
+              <a:t>60</a:t>
             </a:r>
             <a:r>
               <a:rPr>
@@ -5144,6 +5162,24 @@
                 </a:solidFill>
                 <a:latin typeface="Courier"/>
               </a:rPr>
+              <a:t>round</a:t>
+            </a:r>
+            <a:r>
+              <a:rPr>
+                <a:solidFill>
+                  <a:srgbClr val="003B4F"/>
+                </a:solidFill>
+                <a:latin typeface="Courier"/>
+              </a:rPr>
+              <a:t>(</a:t>
+            </a:r>
+            <a:r>
+              <a:rPr>
+                <a:solidFill>
+                  <a:srgbClr val="4758AB"/>
+                </a:solidFill>
+                <a:latin typeface="Courier"/>
+              </a:rPr>
               <a:t>mean</a:t>
             </a:r>
             <a:r>
@@ -5207,6 +5243,24 @@
                 </a:solidFill>
                 <a:latin typeface="Courier"/>
               </a:rPr>
+              <a:t>),</a:t>
+            </a:r>
+            <a:r>
+              <a:rPr>
+                <a:solidFill>
+                  <a:srgbClr val="AD0000"/>
+                </a:solidFill>
+                <a:latin typeface="Courier"/>
+              </a:rPr>
+              <a:t>2</a:t>
+            </a:r>
+            <a:r>
+              <a:rPr>
+                <a:solidFill>
+                  <a:srgbClr val="003B4F"/>
+                </a:solidFill>
+                <a:latin typeface="Courier"/>
+              </a:rPr>
               <a:t>)</a:t>
             </a:r>
             <a:br/>
@@ -5226,6 +5280,24 @@
                 </a:solidFill>
                 <a:latin typeface="Courier"/>
               </a:rPr>
+              <a:t>round</a:t>
+            </a:r>
+            <a:r>
+              <a:rPr>
+                <a:solidFill>
+                  <a:srgbClr val="003B4F"/>
+                </a:solidFill>
+                <a:latin typeface="Courier"/>
+              </a:rPr>
+              <a:t>(</a:t>
+            </a:r>
+            <a:r>
+              <a:rPr>
+                <a:solidFill>
+                  <a:srgbClr val="4758AB"/>
+                </a:solidFill>
+                <a:latin typeface="Courier"/>
+              </a:rPr>
               <a:t>sd</a:t>
             </a:r>
             <a:r>
@@ -5334,7 +5406,25 @@
                 </a:solidFill>
                 <a:latin typeface="Courier"/>
               </a:rPr>
-              <a:t>10</a:t>
+              <a:t>30</a:t>
+            </a:r>
+            <a:r>
+              <a:rPr>
+                <a:solidFill>
+                  <a:srgbClr val="003B4F"/>
+                </a:solidFill>
+                <a:latin typeface="Courier"/>
+              </a:rPr>
+              <a:t>),</a:t>
+            </a:r>
+            <a:r>
+              <a:rPr>
+                <a:solidFill>
+                  <a:srgbClr val="AD0000"/>
+                </a:solidFill>
+                <a:latin typeface="Courier"/>
+              </a:rPr>
+              <a:t>4</a:t>
             </a:r>
             <a:r>
               <a:rPr>
@@ -5363,6 +5453,24 @@
                 </a:solidFill>
                 <a:latin typeface="Courier"/>
               </a:rPr>
+              <a:t>round</a:t>
+            </a:r>
+            <a:r>
+              <a:rPr>
+                <a:solidFill>
+                  <a:srgbClr val="003B4F"/>
+                </a:solidFill>
+                <a:latin typeface="Courier"/>
+              </a:rPr>
+              <a:t>(</a:t>
+            </a:r>
+            <a:r>
+              <a:rPr>
+                <a:solidFill>
+                  <a:srgbClr val="4758AB"/>
+                </a:solidFill>
+                <a:latin typeface="Courier"/>
+              </a:rPr>
               <a:t>mean</a:t>
             </a:r>
             <a:r>
@@ -5426,6 +5534,24 @@
                 </a:solidFill>
                 <a:latin typeface="Courier"/>
               </a:rPr>
+              <a:t>),</a:t>
+            </a:r>
+            <a:r>
+              <a:rPr>
+                <a:solidFill>
+                  <a:srgbClr val="AD0000"/>
+                </a:solidFill>
+                <a:latin typeface="Courier"/>
+              </a:rPr>
+              <a:t>2</a:t>
+            </a:r>
+            <a:r>
+              <a:rPr>
+                <a:solidFill>
+                  <a:srgbClr val="003B4F"/>
+                </a:solidFill>
+                <a:latin typeface="Courier"/>
+              </a:rPr>
               <a:t>)</a:t>
             </a:r>
             <a:br/>
@@ -5445,6 +5571,24 @@
                 </a:solidFill>
                 <a:latin typeface="Courier"/>
               </a:rPr>
+              <a:t>round</a:t>
+            </a:r>
+            <a:r>
+              <a:rPr>
+                <a:solidFill>
+                  <a:srgbClr val="003B4F"/>
+                </a:solidFill>
+                <a:latin typeface="Courier"/>
+              </a:rPr>
+              <a:t>(</a:t>
+            </a:r>
+            <a:r>
+              <a:rPr>
+                <a:solidFill>
+                  <a:srgbClr val="4758AB"/>
+                </a:solidFill>
+                <a:latin typeface="Courier"/>
+              </a:rPr>
               <a:t>sd</a:t>
             </a:r>
             <a:r>
@@ -5554,6 +5698,24 @@
                 <a:latin typeface="Courier"/>
               </a:rPr>
               <a:t>30</a:t>
+            </a:r>
+            <a:r>
+              <a:rPr>
+                <a:solidFill>
+                  <a:srgbClr val="003B4F"/>
+                </a:solidFill>
+                <a:latin typeface="Courier"/>
+              </a:rPr>
+              <a:t>),</a:t>
+            </a:r>
+            <a:r>
+              <a:rPr>
+                <a:solidFill>
+                  <a:srgbClr val="AD0000"/>
+                </a:solidFill>
+                <a:latin typeface="Courier"/>
+              </a:rPr>
+              <a:t>4</a:t>
             </a:r>
             <a:r>
               <a:rPr>
@@ -5582,6 +5744,24 @@
                 </a:solidFill>
                 <a:latin typeface="Courier"/>
               </a:rPr>
+              <a:t>round</a:t>
+            </a:r>
+            <a:r>
+              <a:rPr>
+                <a:solidFill>
+                  <a:srgbClr val="003B4F"/>
+                </a:solidFill>
+                <a:latin typeface="Courier"/>
+              </a:rPr>
+              <a:t>(</a:t>
+            </a:r>
+            <a:r>
+              <a:rPr>
+                <a:solidFill>
+                  <a:srgbClr val="4758AB"/>
+                </a:solidFill>
+                <a:latin typeface="Courier"/>
+              </a:rPr>
               <a:t>mean</a:t>
             </a:r>
             <a:r>
@@ -5645,6 +5825,24 @@
                 </a:solidFill>
                 <a:latin typeface="Courier"/>
               </a:rPr>
+              <a:t>),</a:t>
+            </a:r>
+            <a:r>
+              <a:rPr>
+                <a:solidFill>
+                  <a:srgbClr val="AD0000"/>
+                </a:solidFill>
+                <a:latin typeface="Courier"/>
+              </a:rPr>
+              <a:t>2</a:t>
+            </a:r>
+            <a:r>
+              <a:rPr>
+                <a:solidFill>
+                  <a:srgbClr val="003B4F"/>
+                </a:solidFill>
+                <a:latin typeface="Courier"/>
+              </a:rPr>
               <a:t>)</a:t>
             </a:r>
             <a:br/>
@@ -5664,6 +5862,24 @@
                 </a:solidFill>
                 <a:latin typeface="Courier"/>
               </a:rPr>
+              <a:t>round</a:t>
+            </a:r>
+            <a:r>
+              <a:rPr>
+                <a:solidFill>
+                  <a:srgbClr val="003B4F"/>
+                </a:solidFill>
+                <a:latin typeface="Courier"/>
+              </a:rPr>
+              <a:t>(</a:t>
+            </a:r>
+            <a:r>
+              <a:rPr>
+                <a:solidFill>
+                  <a:srgbClr val="4758AB"/>
+                </a:solidFill>
+                <a:latin typeface="Courier"/>
+              </a:rPr>
               <a:t>sd</a:t>
             </a:r>
             <a:r>
@@ -5772,7 +5988,25 @@
                 </a:solidFill>
                 <a:latin typeface="Courier"/>
               </a:rPr>
-              <a:t>100</a:t>
+              <a:t>60</a:t>
+            </a:r>
+            <a:r>
+              <a:rPr>
+                <a:solidFill>
+                  <a:srgbClr val="003B4F"/>
+                </a:solidFill>
+                <a:latin typeface="Courier"/>
+              </a:rPr>
+              <a:t>),</a:t>
+            </a:r>
+            <a:r>
+              <a:rPr>
+                <a:solidFill>
+                  <a:srgbClr val="AD0000"/>
+                </a:solidFill>
+                <a:latin typeface="Courier"/>
+              </a:rPr>
+              <a:t>4</a:t>
             </a:r>
             <a:r>
               <a:rPr>
@@ -5875,7 +6109,7 @@
                 </a:solidFill>
                 <a:latin typeface="Courier"/>
               </a:rPr>
-              <a:t>10</a:t>
+              <a:t>3</a:t>
             </a:r>
             <a:r>
               <a:rPr>
@@ -5911,7 +6145,7 @@
                 </a:solidFill>
                 <a:latin typeface="Courier"/>
               </a:rPr>
-              <a:t>100</a:t>
+              <a:t>60</a:t>
             </a:r>
             <a:r>
               <a:rPr>
@@ -6054,10 +6288,10 @@
               <a:rPr sz="2000">
                 <a:latin typeface="Courier"/>
               </a:rPr>
-              <a:t>  Sample_Size    Mean        SE
-1          10 302.000 26.607330
-2          30 319.200 12.082989
-3         100 323.328  6.478149</a:t>
+              <a:t>  Sample_Size   Mean      SE
+1           3 278.33 16.6096
+2          30 321.07 12.0926
+3          60 311.78  8.3944</a:t>
             </a:r>
           </a:p>
           <a:p>
@@ -6535,7 +6769,21 @@
                 </a14:m>
                 <a:r>
                   <a:rPr/>
-                  <a:t> depends on - sample s (standard deviation) - sample n - (</a:t>
+                  <a:t> depends on</a:t>
+                </a:r>
+              </a:p>
+              <a:p>
+                <a:pPr lvl="0"/>
+                <a:r>
+                  <a:rPr/>
+                  <a:t>- sample s (standard deviation)</a:t>
+                </a:r>
+              </a:p>
+              <a:p>
+                <a:pPr lvl="0"/>
+                <a:r>
+                  <a:rPr/>
+                  <a:t>- sample n - (</a:t>
                 </a:r>
                 <a14:m>
                   <m:oMath xmlns:m="http://schemas.openxmlformats.org/officeDocument/2006/math">
@@ -6600,7 +6848,14 @@
                 </a:pPr>
                 <a:r>
                   <a:rPr/>
-                  <a:t>How and why? - Decreases with sample n - number - increases with sample s - standard deviation</a:t>
+                  <a:t>How and why?</a:t>
+                </a:r>
+              </a:p>
+              <a:p>
+                <a:pPr lvl="0"/>
+                <a:r>
+                  <a:rPr/>
+                  <a:t>Decreases with sample n - number - increases with sample s - standard deviation</a:t>
                 </a:r>
               </a:p>
               <a:p>
@@ -12012,7 +12267,7 @@
             </a:pPr>
             <a:r>
               <a:rPr sz="2000"/>
-              <a:t>Let’s perform a one-sample t-test to determine if the mean fish length in Toolik Lake differs from 50 mm:</a:t>
+              <a:t>Let’s perform a one-sample t-test to determine if the mean fish length in Lake I3 differs from 260 mm:</a:t>
             </a:r>
           </a:p>
           <a:p>
@@ -12904,9 +13159,26 @@
               <a:rPr b="1"/>
               <a:t>Common interpretations:</a:t>
             </a:r>
+          </a:p>
+          <a:p>
+            <a:pPr lvl="0"/>
             <a:r>
               <a:rPr/>
-              <a:t> - p &lt; 0.05: Strong evidence against H₀ - 0.05 ≤ p &lt; 0.10: Moderate evidence against H₀ - p ≥ 0.10: Insufficient evidence against H₀</a:t>
+              <a:t>- p &lt; 0.05: Strong evidence against H₀</a:t>
+            </a:r>
+          </a:p>
+          <a:p>
+            <a:pPr lvl="0"/>
+            <a:r>
+              <a:rPr/>
+              <a:t>- 0.05 ≤ p &lt; 0.10: Moderate evidence against H₀</a:t>
+            </a:r>
+          </a:p>
+          <a:p>
+            <a:pPr lvl="0"/>
+            <a:r>
+              <a:rPr/>
+              <a:t>- p ≥ 0.10: Insufficient evidence against H₀</a:t>
             </a:r>
           </a:p>
           <a:p>
@@ -12917,9 +13189,26 @@
               <a:rPr b="1"/>
               <a:t>Common misinterpretations:</a:t>
             </a:r>
+          </a:p>
+          <a:p>
+            <a:pPr lvl="0"/>
             <a:r>
               <a:rPr/>
-              <a:t> - p-value is NOT the probability that H₀ is true - p-value is NOT the probability that results occurred by chance - Statistical significance ≠ practical significance</a:t>
+              <a:t>- p-value is NOT the probability that H₀ is true</a:t>
+            </a:r>
+          </a:p>
+          <a:p>
+            <a:pPr lvl="0"/>
+            <a:r>
+              <a:rPr/>
+              <a:t>- p-value is NOT the probability that results occurred by chance</a:t>
+            </a:r>
+          </a:p>
+          <a:p>
+            <a:pPr lvl="0"/>
+            <a:r>
+              <a:rPr/>
+              <a:t>- Statistical significance ≠ practical significance</a:t>
             </a:r>
           </a:p>
         </p:txBody>
@@ -14801,7 +15090,7 @@
             </a:pPr>
             <a:r>
               <a:rPr/>
-              <a:t>Practice Exercise 2: Calculating Z-scores</a:t>
+              <a:t>Practice Exercise 2: Calculating Z-scores of lake I3</a:t>
             </a:r>
           </a:p>
         </p:txBody>
@@ -14839,6 +15128,15 @@
             </a:r>
           </a:p>
           <a:p>
+            <a:pPr lvl="0" indent="0" marL="1270000">
+              <a:buNone/>
+            </a:pPr>
+            <a:r>
+              <a:rPr sz="2000"/>
+              <a:t>Z Score = (length - mean) / standard deviation</a:t>
+            </a:r>
+          </a:p>
+          <a:p>
             <a:pPr lvl="0" indent="0">
               <a:buNone/>
             </a:pPr>
@@ -14877,7 +15175,7 @@
                 </a:solidFill>
                 <a:latin typeface="Courier"/>
               </a:rPr>
-              <a:t>(grayling_df</a:t>
+              <a:t>(i3_df</a:t>
             </a:r>
             <a:r>
               <a:rPr>
@@ -14959,7 +15257,7 @@
                 </a:solidFill>
                 <a:latin typeface="Courier"/>
               </a:rPr>
-              <a:t>(grayling_df</a:t>
+              <a:t>(i3_df</a:t>
             </a:r>
             <a:r>
               <a:rPr>
@@ -15034,7 +15332,7 @@
                 </a:solidFill>
                 <a:latin typeface="Courier"/>
               </a:rPr>
-              <a:t>grayling_df &lt;- grayling_df </a:t>
+              <a:t>i3_df &lt;- i3_df </a:t>
             </a:r>
             <a:r>
               <a:rPr>
@@ -15155,7 +15453,7 @@
                 </a:solidFill>
                 <a:latin typeface="Courier"/>
               </a:rPr>
-              <a:t>(grayling_df)</a:t>
+              <a:t>(i3_df)</a:t>
             </a:r>
           </a:p>
           <a:p>
@@ -15169,12 +15467,12 @@
               <a:t># A tibble: 6 × 6
    site lake  species         length_mm mass_g z_score
   &lt;dbl&gt; &lt;chr&gt; &lt;chr&gt;               &lt;dbl&gt;  &lt;dbl&gt;   &lt;dbl&gt;
-1   113 I3    arctic grayling       266    135  -0.900
-2   113 I3    arctic grayling       290    185  -0.531
-3   113 I3    arctic grayling       262    145  -0.961
-4   113 I3    arctic grayling       275    160  -0.761
-5   113 I3    arctic grayling       240    105  -1.30 
-6   113 I3    arctic grayling       265    145  -0.915</a:t>
+1   113 I3    arctic grayling       266    135  0.0139
+2   113 I3    arctic grayling       290    185  0.862 
+3   113 I3    arctic grayling       262    145 -0.127 
+4   113 I3    arctic grayling       275    160  0.332 
+5   113 I3    arctic grayling       240    105 -0.905 
+6   113 I3    arctic grayling       265    145 -0.0214</a:t>
             </a:r>
           </a:p>
         </p:txBody>
@@ -15246,6 +15544,24 @@
           <a:bodyPr/>
           <a:lstStyle/>
           <a:p>
+            <a:pPr lvl="0" indent="0" marL="0">
+              <a:buNone/>
+            </a:pPr>
+            <a:r>
+              <a:rPr/>
+              <a:t>proportion within 1 standard deviation = sum of absolute values of Z Scores that are less than or equal to 1 divided by the number in the sample…</a:t>
+            </a:r>
+          </a:p>
+          <a:p>
+            <a:pPr lvl="0" indent="0" marL="0">
+              <a:buNone/>
+            </a:pPr>
+            <a:r>
+              <a:rPr/>
+              <a:t>Remember in a true normal distribution it is 68% within 1 std dev.</a:t>
+            </a:r>
+          </a:p>
+          <a:p>
             <a:pPr lvl="0" indent="0">
               <a:buNone/>
             </a:pPr>
@@ -15302,7 +15618,7 @@
                 </a:solidFill>
                 <a:latin typeface="Courier"/>
               </a:rPr>
-              <a:t>(grayling_df</a:t>
+              <a:t>(i3_df</a:t>
             </a:r>
             <a:r>
               <a:rPr>
@@ -15455,7 +15771,7 @@
                 </a:solidFill>
                 <a:latin typeface="Courier"/>
               </a:rPr>
-              <a:t>(grayling_df</a:t>
+              <a:t>(i3_df</a:t>
             </a:r>
             <a:r>
               <a:rPr>
@@ -15629,7 +15945,7 @@
               <a:rPr>
                 <a:latin typeface="Courier"/>
               </a:rPr>
-              <a:t>Proportion within 1 SD: 64.3 %</a:t>
+              <a:t>Proportion within 1 SD: 81.8 %</a:t>
             </a:r>
           </a:p>
         </p:txBody>
@@ -15720,7 +16036,7 @@
             <a:pPr lvl="0"/>
             <a:r>
               <a:rPr/>
-              <a:t>Can solve this by integrating under curve</a:t>
+              <a:t>Can solve this by integrating the area under curve</a:t>
             </a:r>
           </a:p>
           <a:p>
@@ -15750,6 +16066,13 @@
             <a:r>
               <a:rPr/>
               <a:t> (SND)</a:t>
+            </a:r>
+          </a:p>
+          <a:p>
+            <a:pPr lvl="1"/>
+            <a:r>
+              <a:rPr/>
+              <a:t>and can use the proportions from the density curve</a:t>
             </a:r>
           </a:p>
         </p:txBody>

</xml_diff>